<commit_message>
feat: sync report structure and outline workflow PPTs to the new Blueprint Compiler architecture
</commit_message>
<xml_diff>
--- a/output/outline_workflow.pptx
+++ b/output/outline_workflow.pptx
@@ -3259,6 +3259,470 @@
             <a:avLst/>
           </a:prstGeom>
           <a:solidFill>
+            <a:srgbClr val="FFFFFF"/>
+          </a:solidFill>
+          <a:ln w="12700">
+            <a:solidFill>
+              <a:srgbClr val="D2D2D2"/>
+            </a:solidFill>
+          </a:ln>
+        </p:spPr>
+        <p:style>
+          <a:lnRef idx="1">
+            <a:schemeClr val="accent1"/>
+          </a:lnRef>
+          <a:fillRef idx="3">
+            <a:schemeClr val="accent1"/>
+          </a:fillRef>
+          <a:effectRef idx="2">
+            <a:schemeClr val="accent1"/>
+          </a:effectRef>
+          <a:fontRef idx="minor">
+            <a:schemeClr val="lt1"/>
+          </a:fontRef>
+        </p:style>
+        <p:txBody>
+          <a:bodyPr rtlCol="0" anchor="ctr"/>
+          <a:lstStyle/>
+          <a:p>
+            <a:pPr algn="ctr"/>
+          </a:p>
+        </p:txBody>
+      </p:sp>
+      <p:sp>
+        <p:nvSpPr>
+          <p:cNvPr id="7" name="Rectangle 6"/>
+          <p:cNvSpPr/>
+          <p:nvPr/>
+        </p:nvSpPr>
+        <p:spPr>
+          <a:xfrm>
+            <a:off x="360000" y="1260000"/>
+            <a:ext cx="2160000" cy="900000"/>
+          </a:xfrm>
+          <a:prstGeom prst="rect">
+            <a:avLst/>
+          </a:prstGeom>
+          <a:solidFill>
+            <a:srgbClr val="C7000F"/>
+          </a:solidFill>
+          <a:ln>
+            <a:noFill/>
+          </a:ln>
+        </p:spPr>
+        <p:style>
+          <a:lnRef idx="1">
+            <a:schemeClr val="accent1"/>
+          </a:lnRef>
+          <a:fillRef idx="3">
+            <a:schemeClr val="accent1"/>
+          </a:fillRef>
+          <a:effectRef idx="2">
+            <a:schemeClr val="accent1"/>
+          </a:effectRef>
+          <a:fontRef idx="minor">
+            <a:schemeClr val="lt1"/>
+          </a:fontRef>
+        </p:style>
+        <p:txBody>
+          <a:bodyPr rtlCol="0" anchor="ctr"/>
+          <a:lstStyle/>
+          <a:p>
+            <a:pPr algn="ctr"/>
+          </a:p>
+        </p:txBody>
+      </p:sp>
+      <p:sp>
+        <p:nvSpPr>
+          <p:cNvPr id="8" name="TextBox 7"/>
+          <p:cNvSpPr txBox="1"/>
+          <p:nvPr/>
+        </p:nvSpPr>
+        <p:spPr>
+          <a:xfrm>
+            <a:off x="432000" y="1584000"/>
+            <a:ext cx="2015999" cy="360000"/>
+          </a:xfrm>
+          <a:prstGeom prst="rect">
+            <a:avLst/>
+          </a:prstGeom>
+          <a:noFill/>
+        </p:spPr>
+        <p:txBody>
+          <a:bodyPr wrap="square">
+            <a:spAutoFit/>
+          </a:bodyPr>
+          <a:lstStyle/>
+          <a:p>
+            <a:pPr algn="ctr"/>
+            <a:r>
+              <a:rPr sz="1200" b="1">
+                <a:solidFill>
+                  <a:srgbClr val="FFFFFF"/>
+                </a:solidFill>
+                <a:latin typeface="微软雅黑"/>
+              </a:rPr>
+              <a:t>Phase 1: 用户编写意图大纲 (Outline Blueprint)</a:t>
+            </a:r>
+          </a:p>
+        </p:txBody>
+      </p:sp>
+      <p:sp>
+        <p:nvSpPr>
+          <p:cNvPr id="9" name="Rectangle 8"/>
+          <p:cNvSpPr/>
+          <p:nvPr/>
+        </p:nvSpPr>
+        <p:spPr>
+          <a:xfrm>
+            <a:off x="5040000" y="1260000"/>
+            <a:ext cx="18000" cy="900000"/>
+          </a:xfrm>
+          <a:prstGeom prst="rect">
+            <a:avLst/>
+          </a:prstGeom>
+          <a:solidFill>
+            <a:srgbClr val="DCDCDC"/>
+          </a:solidFill>
+          <a:ln>
+            <a:noFill/>
+          </a:ln>
+        </p:spPr>
+        <p:style>
+          <a:lnRef idx="1">
+            <a:schemeClr val="accent1"/>
+          </a:lnRef>
+          <a:fillRef idx="3">
+            <a:schemeClr val="accent1"/>
+          </a:fillRef>
+          <a:effectRef idx="2">
+            <a:schemeClr val="accent1"/>
+          </a:effectRef>
+          <a:fontRef idx="minor">
+            <a:schemeClr val="lt1"/>
+          </a:fontRef>
+        </p:style>
+        <p:txBody>
+          <a:bodyPr rtlCol="0" anchor="ctr"/>
+          <a:lstStyle/>
+          <a:p>
+            <a:pPr algn="ctr"/>
+          </a:p>
+        </p:txBody>
+      </p:sp>
+      <p:sp>
+        <p:nvSpPr>
+          <p:cNvPr id="10" name="Rectangle 9"/>
+          <p:cNvSpPr/>
+          <p:nvPr/>
+        </p:nvSpPr>
+        <p:spPr>
+          <a:xfrm>
+            <a:off x="8280000" y="1260000"/>
+            <a:ext cx="18000" cy="900000"/>
+          </a:xfrm>
+          <a:prstGeom prst="rect">
+            <a:avLst/>
+          </a:prstGeom>
+          <a:solidFill>
+            <a:srgbClr val="DCDCDC"/>
+          </a:solidFill>
+          <a:ln>
+            <a:noFill/>
+          </a:ln>
+        </p:spPr>
+        <p:style>
+          <a:lnRef idx="1">
+            <a:schemeClr val="accent1"/>
+          </a:lnRef>
+          <a:fillRef idx="3">
+            <a:schemeClr val="accent1"/>
+          </a:fillRef>
+          <a:effectRef idx="2">
+            <a:schemeClr val="accent1"/>
+          </a:effectRef>
+          <a:fontRef idx="minor">
+            <a:schemeClr val="lt1"/>
+          </a:fontRef>
+        </p:style>
+        <p:txBody>
+          <a:bodyPr rtlCol="0" anchor="ctr"/>
+          <a:lstStyle/>
+          <a:p>
+            <a:pPr algn="ctr"/>
+          </a:p>
+        </p:txBody>
+      </p:sp>
+      <p:sp>
+        <p:nvSpPr>
+          <p:cNvPr id="11" name="TextBox 10"/>
+          <p:cNvSpPr txBox="1"/>
+          <p:nvPr/>
+        </p:nvSpPr>
+        <p:spPr>
+          <a:xfrm>
+            <a:off x="2700000" y="1332000"/>
+            <a:ext cx="1800000" cy="180000"/>
+          </a:xfrm>
+          <a:prstGeom prst="rect">
+            <a:avLst/>
+          </a:prstGeom>
+          <a:noFill/>
+        </p:spPr>
+        <p:txBody>
+          <a:bodyPr wrap="square">
+            <a:spAutoFit/>
+          </a:bodyPr>
+          <a:lstStyle/>
+          <a:p>
+            <a:pPr algn="l"/>
+            <a:r>
+              <a:rPr sz="1100" b="1">
+                <a:solidFill>
+                  <a:srgbClr val="C7000F"/>
+                </a:solidFill>
+                <a:latin typeface="微软雅黑"/>
+              </a:rPr>
+              <a:t>▶ 引擎核心动作</a:t>
+            </a:r>
+          </a:p>
+        </p:txBody>
+      </p:sp>
+      <p:sp>
+        <p:nvSpPr>
+          <p:cNvPr id="12" name="TextBox 11"/>
+          <p:cNvSpPr txBox="1"/>
+          <p:nvPr/>
+        </p:nvSpPr>
+        <p:spPr>
+          <a:xfrm>
+            <a:off x="2700000" y="1584000"/>
+            <a:ext cx="2160000" cy="540000"/>
+          </a:xfrm>
+          <a:prstGeom prst="rect">
+            <a:avLst/>
+          </a:prstGeom>
+          <a:noFill/>
+        </p:spPr>
+        <p:txBody>
+          <a:bodyPr wrap="square">
+            <a:spAutoFit/>
+          </a:bodyPr>
+          <a:lstStyle/>
+          <a:p>
+            <a:pPr algn="l"/>
+            <a:r>
+              <a:rPr sz="900" b="0">
+                <a:solidFill>
+                  <a:srgbClr val="333333"/>
+                </a:solidFill>
+                <a:latin typeface="微软雅黑"/>
+              </a:rPr>
+              <a:t>用户在富文本编辑器中直接书写自然流畅的报告意图描述。通过 '/' 唤出组件，插入例如 threshold（阈值）、operator（操作符）、indicator（指标）等受控的参数插槽。</a:t>
+            </a:r>
+          </a:p>
+        </p:txBody>
+      </p:sp>
+      <p:sp>
+        <p:nvSpPr>
+          <p:cNvPr id="13" name="TextBox 12"/>
+          <p:cNvSpPr txBox="1"/>
+          <p:nvPr/>
+        </p:nvSpPr>
+        <p:spPr>
+          <a:xfrm>
+            <a:off x="5220000" y="1332000"/>
+            <a:ext cx="1800000" cy="180000"/>
+          </a:xfrm>
+          <a:prstGeom prst="rect">
+            <a:avLst/>
+          </a:prstGeom>
+          <a:noFill/>
+        </p:spPr>
+        <p:txBody>
+          <a:bodyPr wrap="square">
+            <a:spAutoFit/>
+          </a:bodyPr>
+          <a:lstStyle/>
+          <a:p>
+            <a:pPr algn="l"/>
+            <a:r>
+              <a:rPr sz="1100" b="1">
+                <a:solidFill>
+                  <a:srgbClr val="C7000F"/>
+                </a:solidFill>
+                <a:latin typeface="微软雅黑"/>
+              </a:rPr>
+              <a:t>▶ 模板信息运用 (Template)</a:t>
+            </a:r>
+          </a:p>
+        </p:txBody>
+      </p:sp>
+      <p:sp>
+        <p:nvSpPr>
+          <p:cNvPr id="14" name="TextBox 13"/>
+          <p:cNvSpPr txBox="1"/>
+          <p:nvPr/>
+        </p:nvSpPr>
+        <p:spPr>
+          <a:xfrm>
+            <a:off x="5220000" y="1584000"/>
+            <a:ext cx="2880000" cy="540000"/>
+          </a:xfrm>
+          <a:prstGeom prst="rect">
+            <a:avLst/>
+          </a:prstGeom>
+          <a:noFill/>
+        </p:spPr>
+        <p:txBody>
+          <a:bodyPr wrap="square">
+            <a:spAutoFit/>
+          </a:bodyPr>
+          <a:lstStyle/>
+          <a:p>
+            <a:pPr algn="l"/>
+            <a:r>
+              <a:rPr sz="900" b="1">
+                <a:solidFill>
+                  <a:srgbClr val="333333"/>
+                </a:solidFill>
+                <a:latin typeface="微软雅黑"/>
+              </a:rPr>
+              <a:t>将意图和插槽编织为
+outline.document 与 outline.blocks</a:t>
+            </a:r>
+          </a:p>
+        </p:txBody>
+      </p:sp>
+      <p:sp>
+        <p:nvSpPr>
+          <p:cNvPr id="15" name="TextBox 14"/>
+          <p:cNvSpPr txBox="1"/>
+          <p:nvPr/>
+        </p:nvSpPr>
+        <p:spPr>
+          <a:xfrm>
+            <a:off x="8460000" y="1332000"/>
+            <a:ext cx="1800000" cy="180000"/>
+          </a:xfrm>
+          <a:prstGeom prst="rect">
+            <a:avLst/>
+          </a:prstGeom>
+          <a:noFill/>
+        </p:spPr>
+        <p:txBody>
+          <a:bodyPr wrap="square">
+            <a:spAutoFit/>
+          </a:bodyPr>
+          <a:lstStyle/>
+          <a:p>
+            <a:pPr algn="l"/>
+            <a:r>
+              <a:rPr sz="1100" b="1">
+                <a:solidFill>
+                  <a:srgbClr val="C7000F"/>
+                </a:solidFill>
+                <a:latin typeface="微软雅黑"/>
+              </a:rPr>
+              <a:t>▶ 阶段产出与对终稿的影响</a:t>
+            </a:r>
+          </a:p>
+        </p:txBody>
+      </p:sp>
+      <p:sp>
+        <p:nvSpPr>
+          <p:cNvPr id="16" name="TextBox 15"/>
+          <p:cNvSpPr txBox="1"/>
+          <p:nvPr/>
+        </p:nvSpPr>
+        <p:spPr>
+          <a:xfrm>
+            <a:off x="8460000" y="1584000"/>
+            <a:ext cx="3240000" cy="540000"/>
+          </a:xfrm>
+          <a:prstGeom prst="rect">
+            <a:avLst/>
+          </a:prstGeom>
+          <a:noFill/>
+        </p:spPr>
+        <p:txBody>
+          <a:bodyPr wrap="square">
+            <a:spAutoFit/>
+          </a:bodyPr>
+          <a:lstStyle/>
+          <a:p>
+            <a:pPr algn="l"/>
+            <a:r>
+              <a:rPr sz="900" b="0">
+                <a:solidFill>
+                  <a:srgbClr val="333333"/>
+                </a:solidFill>
+                <a:latin typeface="微软雅黑"/>
+              </a:rPr>
+              <a:t>【参数化意图文本】
+例如：“分析范围为近3天，关注存在大于(operator) 8.5(threshold) 的异常数据”</a:t>
+            </a:r>
+          </a:p>
+        </p:txBody>
+      </p:sp>
+      <p:sp>
+        <p:nvSpPr>
+          <p:cNvPr id="17" name="Down Arrow 16"/>
+          <p:cNvSpPr/>
+          <p:nvPr/>
+        </p:nvSpPr>
+        <p:spPr>
+          <a:xfrm>
+            <a:off x="5940000" y="2196000"/>
+            <a:ext cx="216000" cy="288000"/>
+          </a:xfrm>
+          <a:prstGeom prst="downArrow">
+            <a:avLst/>
+          </a:prstGeom>
+          <a:solidFill>
+            <a:srgbClr val="777777"/>
+          </a:solidFill>
+          <a:ln>
+            <a:noFill/>
+          </a:ln>
+        </p:spPr>
+        <p:style>
+          <a:lnRef idx="1">
+            <a:schemeClr val="accent1"/>
+          </a:lnRef>
+          <a:fillRef idx="3">
+            <a:schemeClr val="accent1"/>
+          </a:fillRef>
+          <a:effectRef idx="2">
+            <a:schemeClr val="accent1"/>
+          </a:effectRef>
+          <a:fontRef idx="minor">
+            <a:schemeClr val="lt1"/>
+          </a:fontRef>
+        </p:style>
+        <p:txBody>
+          <a:bodyPr rtlCol="0" anchor="ctr"/>
+          <a:lstStyle/>
+          <a:p>
+            <a:pPr algn="ctr"/>
+          </a:p>
+        </p:txBody>
+      </p:sp>
+      <p:sp>
+        <p:nvSpPr>
+          <p:cNvPr id="18" name="Rectangle 17"/>
+          <p:cNvSpPr/>
+          <p:nvPr/>
+        </p:nvSpPr>
+        <p:spPr>
+          <a:xfrm>
+            <a:off x="360000" y="2520000"/>
+            <a:ext cx="11473200" cy="900000"/>
+          </a:xfrm>
+          <a:prstGeom prst="rect">
+            <a:avLst/>
+          </a:prstGeom>
+          <a:solidFill>
             <a:srgbClr val="F9F9F9"/>
           </a:solidFill>
           <a:ln w="12700">
@@ -3291,13 +3755,13 @@
       </p:sp>
       <p:sp>
         <p:nvSpPr>
-          <p:cNvPr id="7" name="Rectangle 6"/>
+          <p:cNvPr id="19" name="Rectangle 18"/>
           <p:cNvSpPr/>
           <p:nvPr/>
         </p:nvSpPr>
         <p:spPr>
           <a:xfrm>
-            <a:off x="360000" y="1260000"/>
+            <a:off x="360000" y="2520000"/>
             <a:ext cx="2160000" cy="900000"/>
           </a:xfrm>
           <a:prstGeom prst="rect">
@@ -3334,13 +3798,13 @@
       </p:sp>
       <p:sp>
         <p:nvSpPr>
-          <p:cNvPr id="8" name="TextBox 7"/>
+          <p:cNvPr id="20" name="TextBox 19"/>
           <p:cNvSpPr txBox="1"/>
           <p:nvPr/>
         </p:nvSpPr>
         <p:spPr>
           <a:xfrm>
-            <a:off x="432000" y="1584000"/>
+            <a:off x="432000" y="2844000"/>
             <a:ext cx="2015999" cy="360000"/>
           </a:xfrm>
           <a:prstGeom prst="rect">
@@ -3362,20 +3826,20 @@
                 </a:solidFill>
                 <a:latin typeface="微软雅黑"/>
               </a:rPr>
-              <a:t>Phase 1: 模板解析与取数</a:t>
-            </a:r>
-          </a:p>
-        </p:txBody>
-      </p:sp>
-      <p:sp>
-        <p:nvSpPr>
-          <p:cNvPr id="9" name="Rectangle 8"/>
+              <a:t>Phase 2: Agent意图降维编译 (Template Copilot)</a:t>
+            </a:r>
+          </a:p>
+        </p:txBody>
+      </p:sp>
+      <p:sp>
+        <p:nvSpPr>
+          <p:cNvPr id="21" name="Rectangle 20"/>
           <p:cNvSpPr/>
           <p:nvPr/>
         </p:nvSpPr>
         <p:spPr>
           <a:xfrm>
-            <a:off x="5040000" y="1260000"/>
+            <a:off x="5040000" y="2520000"/>
             <a:ext cx="18000" cy="900000"/>
           </a:xfrm>
           <a:prstGeom prst="rect">
@@ -3412,13 +3876,13 @@
       </p:sp>
       <p:sp>
         <p:nvSpPr>
-          <p:cNvPr id="10" name="Rectangle 9"/>
+          <p:cNvPr id="22" name="Rectangle 21"/>
           <p:cNvSpPr/>
           <p:nvPr/>
         </p:nvSpPr>
         <p:spPr>
           <a:xfrm>
-            <a:off x="8280000" y="1260000"/>
+            <a:off x="8280000" y="2520000"/>
             <a:ext cx="18000" cy="900000"/>
           </a:xfrm>
           <a:prstGeom prst="rect">
@@ -3455,13 +3919,13 @@
       </p:sp>
       <p:sp>
         <p:nvSpPr>
-          <p:cNvPr id="11" name="TextBox 10"/>
+          <p:cNvPr id="23" name="TextBox 22"/>
           <p:cNvSpPr txBox="1"/>
           <p:nvPr/>
         </p:nvSpPr>
         <p:spPr>
           <a:xfrm>
-            <a:off x="2700000" y="1332000"/>
+            <a:off x="2700000" y="2592000"/>
             <a:ext cx="1800000" cy="180000"/>
           </a:xfrm>
           <a:prstGeom prst="rect">
@@ -3490,13 +3954,13 @@
       </p:sp>
       <p:sp>
         <p:nvSpPr>
-          <p:cNvPr id="12" name="TextBox 11"/>
+          <p:cNvPr id="24" name="TextBox 23"/>
           <p:cNvSpPr txBox="1"/>
           <p:nvPr/>
         </p:nvSpPr>
         <p:spPr>
           <a:xfrm>
-            <a:off x="2700000" y="1584000"/>
+            <a:off x="2700000" y="2844000"/>
             <a:ext cx="2160000" cy="540000"/>
           </a:xfrm>
           <a:prstGeom prst="rect">
@@ -3518,20 +3982,20 @@
                 </a:solidFill>
                 <a:latin typeface="微软雅黑"/>
               </a:rPr>
-              <a:t>引擎加载 parameters，按 DAG 调度并执行无依赖的 datasets，从数据库查询出客观数值状态。</a:t>
-            </a:r>
-          </a:p>
-        </p:txBody>
-      </p:sp>
-      <p:sp>
-        <p:nvSpPr>
-          <p:cNvPr id="13" name="TextBox 12"/>
+              <a:t>用户点击保存后，Agent (大模型) 通读大纲意图中的所有参数组合，自主进行结构决策：应该用什么数据源？应该用图表（并标注红线）还是表格展示？</a:t>
+            </a:r>
+          </a:p>
+        </p:txBody>
+      </p:sp>
+      <p:sp>
+        <p:nvSpPr>
+          <p:cNvPr id="25" name="TextBox 24"/>
           <p:cNvSpPr txBox="1"/>
           <p:nvPr/>
         </p:nvSpPr>
         <p:spPr>
           <a:xfrm>
-            <a:off x="5220000" y="1332000"/>
+            <a:off x="5220000" y="2592000"/>
             <a:ext cx="1800000" cy="180000"/>
           </a:xfrm>
           <a:prstGeom prst="rect">
@@ -3560,13 +4024,13 @@
       </p:sp>
       <p:sp>
         <p:nvSpPr>
-          <p:cNvPr id="14" name="TextBox 13"/>
+          <p:cNvPr id="26" name="TextBox 25"/>
           <p:cNvSpPr txBox="1"/>
           <p:nvPr/>
         </p:nvSpPr>
         <p:spPr>
           <a:xfrm>
-            <a:off x="5220000" y="1584000"/>
+            <a:off x="5220000" y="2844000"/>
             <a:ext cx="2880000" cy="540000"/>
           </a:xfrm>
           <a:prstGeom prst="rect">
@@ -3588,21 +4052,21 @@
                 </a:solidFill>
                 <a:latin typeface="微软雅黑"/>
               </a:rPr>
-              <a:t>读取 datasets[].source.query
-执行 SQL / 调用 API</a:t>
-            </a:r>
-          </a:p>
-        </p:txBody>
-      </p:sp>
-      <p:sp>
-        <p:nvSpPr>
-          <p:cNvPr id="15" name="TextBox 14"/>
+              <a:t>读取 outline.document
+翻译出对应的 datasets 与 presentation</a:t>
+            </a:r>
+          </a:p>
+        </p:txBody>
+      </p:sp>
+      <p:sp>
+        <p:nvSpPr>
+          <p:cNvPr id="27" name="TextBox 26"/>
           <p:cNvSpPr txBox="1"/>
           <p:nvPr/>
         </p:nvSpPr>
         <p:spPr>
           <a:xfrm>
-            <a:off x="8460000" y="1332000"/>
+            <a:off x="8460000" y="2592000"/>
             <a:ext cx="1800000" cy="180000"/>
           </a:xfrm>
           <a:prstGeom prst="rect">
@@ -3631,13 +4095,13 @@
       </p:sp>
       <p:sp>
         <p:nvSpPr>
-          <p:cNvPr id="16" name="TextBox 15"/>
+          <p:cNvPr id="28" name="TextBox 27"/>
           <p:cNvSpPr txBox="1"/>
           <p:nvPr/>
         </p:nvSpPr>
         <p:spPr>
           <a:xfrm>
-            <a:off x="8460000" y="1584000"/>
+            <a:off x="8460000" y="2844000"/>
             <a:ext cx="3240000" cy="540000"/>
           </a:xfrm>
           <a:prstGeom prst="rect">
@@ -3659,472 +4123,8 @@
                 </a:solidFill>
                 <a:latin typeface="微软雅黑"/>
               </a:rPr>
-              <a:t>【客观事实数据集】
-例如：设备各测点当前温度 92℃，处于超标状态。</a:t>
-            </a:r>
-          </a:p>
-        </p:txBody>
-      </p:sp>
-      <p:sp>
-        <p:nvSpPr>
-          <p:cNvPr id="17" name="Down Arrow 16"/>
-          <p:cNvSpPr/>
-          <p:nvPr/>
-        </p:nvSpPr>
-        <p:spPr>
-          <a:xfrm>
-            <a:off x="5940000" y="2196000"/>
-            <a:ext cx="216000" cy="288000"/>
-          </a:xfrm>
-          <a:prstGeom prst="downArrow">
-            <a:avLst/>
-          </a:prstGeom>
-          <a:solidFill>
-            <a:srgbClr val="777777"/>
-          </a:solidFill>
-          <a:ln>
-            <a:noFill/>
-          </a:ln>
-        </p:spPr>
-        <p:style>
-          <a:lnRef idx="1">
-            <a:schemeClr val="accent1"/>
-          </a:lnRef>
-          <a:fillRef idx="3">
-            <a:schemeClr val="accent1"/>
-          </a:fillRef>
-          <a:effectRef idx="2">
-            <a:schemeClr val="accent1"/>
-          </a:effectRef>
-          <a:fontRef idx="minor">
-            <a:schemeClr val="lt1"/>
-          </a:fontRef>
-        </p:style>
-        <p:txBody>
-          <a:bodyPr rtlCol="0" anchor="ctr"/>
-          <a:lstStyle/>
-          <a:p>
-            <a:pPr algn="ctr"/>
-          </a:p>
-        </p:txBody>
-      </p:sp>
-      <p:sp>
-        <p:nvSpPr>
-          <p:cNvPr id="18" name="Rectangle 17"/>
-          <p:cNvSpPr/>
-          <p:nvPr/>
-        </p:nvSpPr>
-        <p:spPr>
-          <a:xfrm>
-            <a:off x="360000" y="2520000"/>
-            <a:ext cx="11473200" cy="900000"/>
-          </a:xfrm>
-          <a:prstGeom prst="rect">
-            <a:avLst/>
-          </a:prstGeom>
-          <a:solidFill>
-            <a:srgbClr val="FFFFFF"/>
-          </a:solidFill>
-          <a:ln w="12700">
-            <a:solidFill>
-              <a:srgbClr val="D2D2D2"/>
-            </a:solidFill>
-          </a:ln>
-        </p:spPr>
-        <p:style>
-          <a:lnRef idx="1">
-            <a:schemeClr val="accent1"/>
-          </a:lnRef>
-          <a:fillRef idx="3">
-            <a:schemeClr val="accent1"/>
-          </a:fillRef>
-          <a:effectRef idx="2">
-            <a:schemeClr val="accent1"/>
-          </a:effectRef>
-          <a:fontRef idx="minor">
-            <a:schemeClr val="lt1"/>
-          </a:fontRef>
-        </p:style>
-        <p:txBody>
-          <a:bodyPr rtlCol="0" anchor="ctr"/>
-          <a:lstStyle/>
-          <a:p>
-            <a:pPr algn="ctr"/>
-          </a:p>
-        </p:txBody>
-      </p:sp>
-      <p:sp>
-        <p:nvSpPr>
-          <p:cNvPr id="19" name="Rectangle 18"/>
-          <p:cNvSpPr/>
-          <p:nvPr/>
-        </p:nvSpPr>
-        <p:spPr>
-          <a:xfrm>
-            <a:off x="360000" y="2520000"/>
-            <a:ext cx="2160000" cy="900000"/>
-          </a:xfrm>
-          <a:prstGeom prst="rect">
-            <a:avLst/>
-          </a:prstGeom>
-          <a:solidFill>
-            <a:srgbClr val="C7000F"/>
-          </a:solidFill>
-          <a:ln>
-            <a:noFill/>
-          </a:ln>
-        </p:spPr>
-        <p:style>
-          <a:lnRef idx="1">
-            <a:schemeClr val="accent1"/>
-          </a:lnRef>
-          <a:fillRef idx="3">
-            <a:schemeClr val="accent1"/>
-          </a:fillRef>
-          <a:effectRef idx="2">
-            <a:schemeClr val="accent1"/>
-          </a:effectRef>
-          <a:fontRef idx="minor">
-            <a:schemeClr val="lt1"/>
-          </a:fontRef>
-        </p:style>
-        <p:txBody>
-          <a:bodyPr rtlCol="0" anchor="ctr"/>
-          <a:lstStyle/>
-          <a:p>
-            <a:pPr algn="ctr"/>
-          </a:p>
-        </p:txBody>
-      </p:sp>
-      <p:sp>
-        <p:nvSpPr>
-          <p:cNvPr id="20" name="TextBox 19"/>
-          <p:cNvSpPr txBox="1"/>
-          <p:nvPr/>
-        </p:nvSpPr>
-        <p:spPr>
-          <a:xfrm>
-            <a:off x="432000" y="2844000"/>
-            <a:ext cx="2015999" cy="360000"/>
-          </a:xfrm>
-          <a:prstGeom prst="rect">
-            <a:avLst/>
-          </a:prstGeom>
-          <a:noFill/>
-        </p:spPr>
-        <p:txBody>
-          <a:bodyPr wrap="square">
-            <a:spAutoFit/>
-          </a:bodyPr>
-          <a:lstStyle/>
-          <a:p>
-            <a:pPr algn="ctr"/>
-            <a:r>
-              <a:rPr sz="1200" b="1">
-                <a:solidFill>
-                  <a:srgbClr val="FFFFFF"/>
-                </a:solidFill>
-                <a:latin typeface="微软雅黑"/>
-              </a:rPr>
-              <a:t>Phase 2: 大纲初稿生成 (Draft)</a:t>
-            </a:r>
-          </a:p>
-        </p:txBody>
-      </p:sp>
-      <p:sp>
-        <p:nvSpPr>
-          <p:cNvPr id="21" name="Rectangle 20"/>
-          <p:cNvSpPr/>
-          <p:nvPr/>
-        </p:nvSpPr>
-        <p:spPr>
-          <a:xfrm>
-            <a:off x="5040000" y="2520000"/>
-            <a:ext cx="18000" cy="900000"/>
-          </a:xfrm>
-          <a:prstGeom prst="rect">
-            <a:avLst/>
-          </a:prstGeom>
-          <a:solidFill>
-            <a:srgbClr val="DCDCDC"/>
-          </a:solidFill>
-          <a:ln>
-            <a:noFill/>
-          </a:ln>
-        </p:spPr>
-        <p:style>
-          <a:lnRef idx="1">
-            <a:schemeClr val="accent1"/>
-          </a:lnRef>
-          <a:fillRef idx="3">
-            <a:schemeClr val="accent1"/>
-          </a:fillRef>
-          <a:effectRef idx="2">
-            <a:schemeClr val="accent1"/>
-          </a:effectRef>
-          <a:fontRef idx="minor">
-            <a:schemeClr val="lt1"/>
-          </a:fontRef>
-        </p:style>
-        <p:txBody>
-          <a:bodyPr rtlCol="0" anchor="ctr"/>
-          <a:lstStyle/>
-          <a:p>
-            <a:pPr algn="ctr"/>
-          </a:p>
-        </p:txBody>
-      </p:sp>
-      <p:sp>
-        <p:nvSpPr>
-          <p:cNvPr id="22" name="Rectangle 21"/>
-          <p:cNvSpPr/>
-          <p:nvPr/>
-        </p:nvSpPr>
-        <p:spPr>
-          <a:xfrm>
-            <a:off x="8280000" y="2520000"/>
-            <a:ext cx="18000" cy="900000"/>
-          </a:xfrm>
-          <a:prstGeom prst="rect">
-            <a:avLst/>
-          </a:prstGeom>
-          <a:solidFill>
-            <a:srgbClr val="DCDCDC"/>
-          </a:solidFill>
-          <a:ln>
-            <a:noFill/>
-          </a:ln>
-        </p:spPr>
-        <p:style>
-          <a:lnRef idx="1">
-            <a:schemeClr val="accent1"/>
-          </a:lnRef>
-          <a:fillRef idx="3">
-            <a:schemeClr val="accent1"/>
-          </a:fillRef>
-          <a:effectRef idx="2">
-            <a:schemeClr val="accent1"/>
-          </a:effectRef>
-          <a:fontRef idx="minor">
-            <a:schemeClr val="lt1"/>
-          </a:fontRef>
-        </p:style>
-        <p:txBody>
-          <a:bodyPr rtlCol="0" anchor="ctr"/>
-          <a:lstStyle/>
-          <a:p>
-            <a:pPr algn="ctr"/>
-          </a:p>
-        </p:txBody>
-      </p:sp>
-      <p:sp>
-        <p:nvSpPr>
-          <p:cNvPr id="23" name="TextBox 22"/>
-          <p:cNvSpPr txBox="1"/>
-          <p:nvPr/>
-        </p:nvSpPr>
-        <p:spPr>
-          <a:xfrm>
-            <a:off x="2700000" y="2592000"/>
-            <a:ext cx="1800000" cy="180000"/>
-          </a:xfrm>
-          <a:prstGeom prst="rect">
-            <a:avLst/>
-          </a:prstGeom>
-          <a:noFill/>
-        </p:spPr>
-        <p:txBody>
-          <a:bodyPr wrap="square">
-            <a:spAutoFit/>
-          </a:bodyPr>
-          <a:lstStyle/>
-          <a:p>
-            <a:pPr algn="l"/>
-            <a:r>
-              <a:rPr sz="1100" b="1">
-                <a:solidFill>
-                  <a:srgbClr val="C7000F"/>
-                </a:solidFill>
-                <a:latin typeface="微软雅黑"/>
-              </a:rPr>
-              <a:t>▶ 引擎核心动作</a:t>
-            </a:r>
-          </a:p>
-        </p:txBody>
-      </p:sp>
-      <p:sp>
-        <p:nvSpPr>
-          <p:cNvPr id="24" name="TextBox 23"/>
-          <p:cNvSpPr txBox="1"/>
-          <p:nvPr/>
-        </p:nvSpPr>
-        <p:spPr>
-          <a:xfrm>
-            <a:off x="2700000" y="2844000"/>
-            <a:ext cx="2160000" cy="540000"/>
-          </a:xfrm>
-          <a:prstGeom prst="rect">
-            <a:avLst/>
-          </a:prstGeom>
-          <a:noFill/>
-        </p:spPr>
-        <p:txBody>
-          <a:bodyPr wrap="square">
-            <a:spAutoFit/>
-          </a:bodyPr>
-          <a:lstStyle/>
-          <a:p>
-            <a:pPr algn="l"/>
-            <a:r>
-              <a:rPr sz="900" b="0">
-                <a:solidFill>
-                  <a:srgbClr val="333333"/>
-                </a:solidFill>
-                <a:latin typeface="微软雅黑"/>
-              </a:rPr>
-              <a:t>利用查出的事实数据，注入大纲层预设的大纲指令，让 LLM 快速生成每个章节的“剧情摘要”。</a:t>
-            </a:r>
-          </a:p>
-        </p:txBody>
-      </p:sp>
-      <p:sp>
-        <p:nvSpPr>
-          <p:cNvPr id="25" name="TextBox 24"/>
-          <p:cNvSpPr txBox="1"/>
-          <p:nvPr/>
-        </p:nvSpPr>
-        <p:spPr>
-          <a:xfrm>
-            <a:off x="5220000" y="2592000"/>
-            <a:ext cx="1800000" cy="180000"/>
-          </a:xfrm>
-          <a:prstGeom prst="rect">
-            <a:avLst/>
-          </a:prstGeom>
-          <a:noFill/>
-        </p:spPr>
-        <p:txBody>
-          <a:bodyPr wrap="square">
-            <a:spAutoFit/>
-          </a:bodyPr>
-          <a:lstStyle/>
-          <a:p>
-            <a:pPr algn="l"/>
-            <a:r>
-              <a:rPr sz="1100" b="1">
-                <a:solidFill>
-                  <a:srgbClr val="C7000F"/>
-                </a:solidFill>
-                <a:latin typeface="微软雅黑"/>
-              </a:rPr>
-              <a:t>▶ 模板信息运用 (Template)</a:t>
-            </a:r>
-          </a:p>
-        </p:txBody>
-      </p:sp>
-      <p:sp>
-        <p:nvSpPr>
-          <p:cNvPr id="26" name="TextBox 25"/>
-          <p:cNvSpPr txBox="1"/>
-          <p:nvPr/>
-        </p:nvSpPr>
-        <p:spPr>
-          <a:xfrm>
-            <a:off x="5220000" y="2844000"/>
-            <a:ext cx="2880000" cy="540000"/>
-          </a:xfrm>
-          <a:prstGeom prst="rect">
-            <a:avLst/>
-          </a:prstGeom>
-          <a:noFill/>
-        </p:spPr>
-        <p:txBody>
-          <a:bodyPr wrap="square">
-            <a:spAutoFit/>
-          </a:bodyPr>
-          <a:lstStyle/>
-          <a:p>
-            <a:pPr algn="l"/>
-            <a:r>
-              <a:rPr sz="900" b="1">
-                <a:solidFill>
-                  <a:srgbClr val="333333"/>
-                </a:solidFill>
-                <a:latin typeface="微软雅黑"/>
-              </a:rPr>
-              <a:t>读取 outline.draft_prompt
-结合 parameters + 客观事实</a:t>
-            </a:r>
-          </a:p>
-        </p:txBody>
-      </p:sp>
-      <p:sp>
-        <p:nvSpPr>
-          <p:cNvPr id="27" name="TextBox 26"/>
-          <p:cNvSpPr txBox="1"/>
-          <p:nvPr/>
-        </p:nvSpPr>
-        <p:spPr>
-          <a:xfrm>
-            <a:off x="8460000" y="2592000"/>
-            <a:ext cx="1800000" cy="180000"/>
-          </a:xfrm>
-          <a:prstGeom prst="rect">
-            <a:avLst/>
-          </a:prstGeom>
-          <a:noFill/>
-        </p:spPr>
-        <p:txBody>
-          <a:bodyPr wrap="square">
-            <a:spAutoFit/>
-          </a:bodyPr>
-          <a:lstStyle/>
-          <a:p>
-            <a:pPr algn="l"/>
-            <a:r>
-              <a:rPr sz="1100" b="1">
-                <a:solidFill>
-                  <a:srgbClr val="C7000F"/>
-                </a:solidFill>
-                <a:latin typeface="微软雅黑"/>
-              </a:rPr>
-              <a:t>▶ 阶段产出与对终稿的影响</a:t>
-            </a:r>
-          </a:p>
-        </p:txBody>
-      </p:sp>
-      <p:sp>
-        <p:nvSpPr>
-          <p:cNvPr id="28" name="TextBox 27"/>
-          <p:cNvSpPr txBox="1"/>
-          <p:nvPr/>
-        </p:nvSpPr>
-        <p:spPr>
-          <a:xfrm>
-            <a:off x="8460000" y="2844000"/>
-            <a:ext cx="3240000" cy="540000"/>
-          </a:xfrm>
-          <a:prstGeom prst="rect">
-            <a:avLst/>
-          </a:prstGeom>
-          <a:noFill/>
-        </p:spPr>
-        <p:txBody>
-          <a:bodyPr wrap="square">
-            <a:spAutoFit/>
-          </a:bodyPr>
-          <a:lstStyle/>
-          <a:p>
-            <a:pPr algn="l"/>
-            <a:r>
-              <a:rPr sz="900" b="0">
-                <a:solidFill>
-                  <a:srgbClr val="333333"/>
-                </a:solidFill>
-                <a:latin typeface="微软雅黑"/>
-              </a:rPr>
-              <a:t>【大纲预览文本】
-例如：“发现设备测点超温现象，本章将讨论轴承磨损的可能性。”</a:t>
+              <a:t>【编译后的布局与数据方案】
+例如：自动生成取近3天趋势的 nl2sql + 挂载折线图 chart 控件。</a:t>
             </a:r>
           </a:p>
         </p:txBody>
@@ -4290,7 +4290,7 @@
                 </a:solidFill>
                 <a:latin typeface="微软雅黑"/>
               </a:rPr>
-              <a:t>Phase 3: 用户界面交互 (WYSIWYG)</a:t>
+              <a:t>Phase 3: 框架固化为标准模板</a:t>
             </a:r>
           </a:p>
         </p:txBody>
@@ -4446,7 +4446,7 @@
                 </a:solidFill>
                 <a:latin typeface="微软雅黑"/>
               </a:rPr>
-              <a:t>用户在界面看到大纲进行修改。若用户补充了数据库查不到的观察（如“现场闻到焦味”），即发生“意图越界”。</a:t>
+              <a:t>Agent 编译生成的技术结构被正式保存为底层标准 YAML 配置，真正做到“大纲归大纲参数，底层归严谨取数”，避免每次跑批都调用大模型的长文本推理成本。</a:t>
             </a:r>
           </a:p>
         </p:txBody>
@@ -4516,8 +4516,8 @@
                 </a:solidFill>
                 <a:latin typeface="微软雅黑"/>
               </a:rPr>
-              <a:t>受控于 presentation.user_editable 标志
-系统绑定修改至 {$user_note} 变量</a:t>
+              <a:t>固化到 content 节点的
+datasets 与 presentation</a:t>
             </a:r>
           </a:p>
         </p:txBody>
@@ -4587,8 +4587,8 @@
                 </a:solidFill>
                 <a:latin typeface="微软雅黑"/>
               </a:rPr>
-              <a:t>【强意图变量/上下文】
-用户的补充文字、对主旨的修改，被作为新的 Context 保存。</a:t>
+              <a:t>【静态化的数据流管道】
+不再有“大纲意图”，全部降维成确定的数据流管道模型。</a:t>
             </a:r>
           </a:p>
         </p:txBody>
@@ -4754,7 +4754,7 @@
                 </a:solidFill>
                 <a:latin typeface="微软雅黑"/>
               </a:rPr>
-              <a:t>Phase 4: 最终报告编织 (AI Synthesis)</a:t>
+              <a:t>Phase 4: 运行时数据跑批 (Data Engine)</a:t>
             </a:r>
           </a:p>
         </p:txBody>
@@ -4910,7 +4910,7 @@
                 </a:solidFill>
                 <a:latin typeface="微软雅黑"/>
               </a:rPr>
-              <a:t>不再僵硬使用 SQL，而是将【客观事实】+【用户强意图】共同注入 ai_synthesis。AI 将用户补充的越界信息作为“现场人工观察”融入专业诊断，不引发逻辑断裂。</a:t>
+              <a:t>每月/每季度自动跑批时，数据引擎拉取上述固化好的模板配置，从数据库查询出真实的传感器客观数值，按照规定好的图表/表格要求完成自动渲染编织。</a:t>
             </a:r>
           </a:p>
         </p:txBody>
@@ -4980,8 +4980,8 @@
                 </a:solidFill>
                 <a:latin typeface="微软雅黑"/>
               </a:rPr>
-              <a:t>执行依赖尾部的 datasets (kind: ai_synthesis)
-prompt_template 包含 {$user_note}</a:t>
+              <a:t>执行依赖尾部的 datasets 
+结合真实数据渲染 presentation 视图</a:t>
             </a:r>
           </a:p>
         </p:txBody>
@@ -5051,8 +5051,8 @@
                 </a:solidFill>
                 <a:latin typeface="微软雅黑"/>
               </a:rPr>
-              <a:t>【最终正式报告段落】
-“结合系统记录的超温事实与现场排查反馈的金属性异味，判定为...”</a:t>
+              <a:t>【最终正式报告】
+“生成一份包含近 3 天振幅的高精度折线图，并在 8.5 处标注了红线。”</a:t>
             </a:r>
           </a:p>
         </p:txBody>

</xml_diff>